<commit_message>
?????????? ?????? ??????????? (??? ??????)
</commit_message>
<xml_diff>
--- a/prezentacii/Karl-Linney-chistaya.pptx
+++ b/prezentacii/Karl-Linney-chistaya.pptx
@@ -1,6 +1,6 @@
 
 <file path=ppt/presentation.xml><?xml version="1.0" encoding="utf-8"?>
-<p:presentation xmlns:a="http://schemas.openxmlformats.org/drawingml/2006/main" xmlns:r="http://schemas.openxmlformats.org/officeDocument/2006/relationships" xmlns:p="http://schemas.openxmlformats.org/presentationml/2006/main" saveSubsetFonts="1">
+<p:presentation xmlns:a="http://schemas.openxmlformats.org/drawingml/2006/main" xmlns:r="http://schemas.openxmlformats.org/officeDocument/2006/relationships" xmlns:p="http://schemas.openxmlformats.org/presentationml/2006/main">
   <p:sldMasterIdLst>
     <p:sldMasterId id="2147483648" r:id="rId1"/>
   </p:sldMasterIdLst>
@@ -14,6 +14,98 @@
   </p:sldIdLst>
   <p:sldSz cx="12192000" cy="6858000"/>
   <p:notesSz cx="6858000" cy="9144000"/>
+  <p:defaultTextStyle>
+    <a:lvl1pPr marL="0" algn="l" defTabSz="914400" rtl="0" eaLnBrk="1" latinLnBrk="0" hangingPunct="1">
+      <a:defRPr sz="1800" kern="1200">
+        <a:solidFill>
+          <a:schemeClr val="tx1"/>
+        </a:solidFill>
+        <a:latin typeface="+mn-lt"/>
+        <a:ea typeface="+mn-ea"/>
+        <a:cs typeface="+mn-cs"/>
+      </a:defRPr>
+    </a:lvl1pPr>
+    <a:lvl2pPr marL="457200" algn="l" defTabSz="914400" rtl="0" eaLnBrk="1" latinLnBrk="0" hangingPunct="1">
+      <a:defRPr sz="1800" kern="1200">
+        <a:solidFill>
+          <a:schemeClr val="tx1"/>
+        </a:solidFill>
+        <a:latin typeface="+mn-lt"/>
+        <a:ea typeface="+mn-ea"/>
+        <a:cs typeface="+mn-cs"/>
+      </a:defRPr>
+    </a:lvl2pPr>
+    <a:lvl3pPr marL="914400" algn="l" defTabSz="914400" rtl="0" eaLnBrk="1" latinLnBrk="0" hangingPunct="1">
+      <a:defRPr sz="1800" kern="1200">
+        <a:solidFill>
+          <a:schemeClr val="tx1"/>
+        </a:solidFill>
+        <a:latin typeface="+mn-lt"/>
+        <a:ea typeface="+mn-ea"/>
+        <a:cs typeface="+mn-cs"/>
+      </a:defRPr>
+    </a:lvl3pPr>
+    <a:lvl4pPr marL="1371600" algn="l" defTabSz="914400" rtl="0" eaLnBrk="1" latinLnBrk="0" hangingPunct="1">
+      <a:defRPr sz="1800" kern="1200">
+        <a:solidFill>
+          <a:schemeClr val="tx1"/>
+        </a:solidFill>
+        <a:latin typeface="+mn-lt"/>
+        <a:ea typeface="+mn-ea"/>
+        <a:cs typeface="+mn-cs"/>
+      </a:defRPr>
+    </a:lvl4pPr>
+    <a:lvl5pPr marL="1828800" algn="l" defTabSz="914400" rtl="0" eaLnBrk="1" latinLnBrk="0" hangingPunct="1">
+      <a:defRPr sz="1800" kern="1200">
+        <a:solidFill>
+          <a:schemeClr val="tx1"/>
+        </a:solidFill>
+        <a:latin typeface="+mn-lt"/>
+        <a:ea typeface="+mn-ea"/>
+        <a:cs typeface="+mn-cs"/>
+      </a:defRPr>
+    </a:lvl5pPr>
+    <a:lvl6pPr marL="2286000" algn="l" defTabSz="914400" rtl="0" eaLnBrk="1" latinLnBrk="0" hangingPunct="1">
+      <a:defRPr sz="1800" kern="1200">
+        <a:solidFill>
+          <a:schemeClr val="tx1"/>
+        </a:solidFill>
+        <a:latin typeface="+mn-lt"/>
+        <a:ea typeface="+mn-ea"/>
+        <a:cs typeface="+mn-cs"/>
+      </a:defRPr>
+    </a:lvl6pPr>
+    <a:lvl7pPr marL="2743200" algn="l" defTabSz="914400" rtl="0" eaLnBrk="1" latinLnBrk="0" hangingPunct="1">
+      <a:defRPr sz="1800" kern="1200">
+        <a:solidFill>
+          <a:schemeClr val="tx1"/>
+        </a:solidFill>
+        <a:latin typeface="+mn-lt"/>
+        <a:ea typeface="+mn-ea"/>
+        <a:cs typeface="+mn-cs"/>
+      </a:defRPr>
+    </a:lvl7pPr>
+    <a:lvl8pPr marL="3200400" algn="l" defTabSz="914400" rtl="0" eaLnBrk="1" latinLnBrk="0" hangingPunct="1">
+      <a:defRPr sz="1800" kern="1200">
+        <a:solidFill>
+          <a:schemeClr val="tx1"/>
+        </a:solidFill>
+        <a:latin typeface="+mn-lt"/>
+        <a:ea typeface="+mn-ea"/>
+        <a:cs typeface="+mn-cs"/>
+      </a:defRPr>
+    </a:lvl8pPr>
+    <a:lvl9pPr marL="3657600" algn="l" defTabSz="914400" rtl="0" eaLnBrk="1" latinLnBrk="0" hangingPunct="1">
+      <a:defRPr sz="1800" kern="1200">
+        <a:solidFill>
+          <a:schemeClr val="tx1"/>
+        </a:solidFill>
+        <a:latin typeface="+mn-lt"/>
+        <a:ea typeface="+mn-ea"/>
+        <a:cs typeface="+mn-cs"/>
+      </a:defRPr>
+    </a:lvl9pPr>
+  </p:defaultTextStyle>
 </p:presentation>
 </file>
 
@@ -45,6 +137,11 @@
 <file path=ppt/slideMasters/slideMaster1.xml><?xml version="1.0" encoding="utf-8"?>
 <p:sldMaster xmlns:a="http://schemas.openxmlformats.org/drawingml/2006/main" xmlns:r="http://schemas.openxmlformats.org/officeDocument/2006/relationships" xmlns:p="http://schemas.openxmlformats.org/presentationml/2006/main">
   <p:cSld>
+    <p:bg>
+      <p:bgRef idx="1001">
+        <a:schemeClr val="bg1"/>
+      </p:bgRef>
+    </p:bg>
     <p:spTree>
       <p:nvGrpSpPr>
         <p:cNvPr id="1" name=""/>
@@ -65,6 +162,11 @@
   <p:sldLayoutIdLst>
     <p:sldLayoutId id="2147483649" r:id="rId1"/>
   </p:sldLayoutIdLst>
+  <p:txStyles>
+    <p:titleStyle/>
+    <p:bodyStyle/>
+    <p:otherStyle/>
+  </p:txStyles>
 </p:sldMaster>
 </file>
 
@@ -156,9 +258,9 @@
                 <a:solidFill>
                   <a:srgbClr val="FFFFFF"/>
                 </a:solidFill>
-                <a:latin typeface="Segoe UI"/>
-                <a:ea typeface="Segoe UI"/>
-                <a:cs typeface="Segoe UI"/>
+                <a:latin typeface="Segoe UI" panose="020B0502040204020203"/>
+                <a:ea typeface="Segoe UI" panose="020B0502040204020203"/>
+                <a:cs typeface="Segoe UI" panose="020B0502040204020203"/>
               </a:rPr>
               <a:t>биография · 1707–1778</a:t>
             </a:r>
@@ -205,9 +307,9 @@
                 <a:solidFill>
                   <a:srgbClr val="202124"/>
                 </a:solidFill>
-                <a:latin typeface="Segoe UI"/>
-                <a:ea typeface="Segoe UI"/>
-                <a:cs typeface="Segoe UI"/>
+                <a:latin typeface="Segoe UI" panose="020B0502040204020203"/>
+                <a:ea typeface="Segoe UI" panose="020B0502040204020203"/>
+                <a:cs typeface="Segoe UI" panose="020B0502040204020203"/>
               </a:rPr>
               <a:t>Карл Линней</a:t>
             </a:r>
@@ -219,9 +321,9 @@
                 <a:solidFill>
                   <a:srgbClr val="202124"/>
                 </a:solidFill>
-                <a:latin typeface="Segoe UI"/>
-                <a:ea typeface="Segoe UI"/>
-                <a:cs typeface="Segoe UI"/>
+                <a:latin typeface="Segoe UI" panose="020B0502040204020203"/>
+                <a:ea typeface="Segoe UI" panose="020B0502040204020203"/>
+                <a:cs typeface="Segoe UI" panose="020B0502040204020203"/>
               </a:rPr>
               <a:t>— отец систематики</a:t>
             </a:r>
@@ -268,9 +370,9 @@
                 <a:solidFill>
                   <a:srgbClr val="5F6368"/>
                 </a:solidFill>
-                <a:latin typeface="Segoe UI"/>
-                <a:ea typeface="Segoe UI"/>
-                <a:cs typeface="Segoe UI"/>
+                <a:latin typeface="Segoe UI" panose="020B0502040204020203"/>
+                <a:ea typeface="Segoe UI" panose="020B0502040204020203"/>
+                <a:cs typeface="Segoe UI" panose="020B0502040204020203"/>
               </a:rPr>
               <a:t>Шведский учёный, который навёл порядок во всём живом мире.</a:t>
             </a:r>
@@ -286,8 +388,8 @@
         </p:nvSpPr>
         <p:spPr>
           <a:xfrm>
-            <a:off x="765175" y="3364805"/>
-            <a:ext cx="1898650" cy="2355850"/>
+            <a:off x="7176135" y="548640"/>
+            <a:ext cx="4027805" cy="5123815"/>
           </a:xfrm>
           <a:prstGeom prst="roundRect">
             <a:avLst>
@@ -302,6 +404,12 @@
             <a:miter lim="800000"/>
           </a:ln>
         </p:spPr>
+        <p:txBody>
+          <a:bodyPr/>
+          <a:p>
+            <a:endParaRPr lang="ru-RU" altLang="en-US"/>
+          </a:p>
+        </p:txBody>
       </p:sp>
       <p:pic>
         <p:nvPicPr>
@@ -312,16 +420,16 @@
           <p:nvPr/>
         </p:nvPicPr>
         <p:blipFill>
-          <a:blip r:embed="rId2"/>
-          <a:srcRect l="1046" t="0" r="1046" b="0"/>
+          <a:blip r:embed="rId1"/>
+          <a:srcRect l="1046" r="1046"/>
           <a:stretch>
             <a:fillRect/>
           </a:stretch>
         </p:blipFill>
         <p:spPr>
           <a:xfrm>
-            <a:off x="768350" y="3367980"/>
-            <a:ext cx="1892300" cy="2349500"/>
+            <a:off x="7176135" y="549275"/>
+            <a:ext cx="4028440" cy="5123180"/>
           </a:xfrm>
           <a:prstGeom prst="rect">
             <a:avLst/>
@@ -331,6 +439,72 @@
           </a:ln>
         </p:spPr>
       </p:pic>
+      <p:sp>
+        <p:nvSpPr>
+          <p:cNvPr id="12" name="Текстовое поле 11"/>
+          <p:cNvSpPr txBox="1"/>
+          <p:nvPr/>
+        </p:nvSpPr>
+        <p:spPr>
+          <a:xfrm>
+            <a:off x="695325" y="3184525"/>
+            <a:ext cx="4064000" cy="645160"/>
+          </a:xfrm>
+          <a:prstGeom prst="rect">
+            <a:avLst/>
+          </a:prstGeom>
+          <a:noFill/>
+        </p:spPr>
+        <p:txBody>
+          <a:bodyPr wrap="square" rtlCol="0">
+            <a:spAutoFit/>
+          </a:bodyPr>
+          <a:p>
+            <a:pPr algn="l"/>
+            <a:r>
+              <a:rPr lang="ru-RU" altLang="en-US">
+                <a:solidFill>
+                  <a:schemeClr val="tx1">
+                    <a:lumMod val="65000"/>
+                    <a:lumOff val="35000"/>
+                  </a:schemeClr>
+                </a:solidFill>
+              </a:rPr>
+              <a:t>Выполнила</a:t>
+            </a:r>
+            <a:r>
+              <a:rPr lang="en-US" altLang="en-US">
+                <a:solidFill>
+                  <a:schemeClr val="tx1">
+                    <a:lumMod val="65000"/>
+                    <a:lumOff val="35000"/>
+                  </a:schemeClr>
+                </a:solidFill>
+              </a:rPr>
+              <a:t>:</a:t>
+            </a:r>
+            <a:r>
+              <a:rPr lang="ru-RU" altLang="en-US">
+                <a:solidFill>
+                  <a:schemeClr val="tx1">
+                    <a:lumMod val="65000"/>
+                    <a:lumOff val="35000"/>
+                  </a:schemeClr>
+                </a:solidFill>
+              </a:rPr>
+              <a:t> Самущенко Вероника ученица 5Г класса</a:t>
+            </a:r>
+            <a:endParaRPr lang="ru-RU" altLang="en-US">
+              <a:solidFill>
+                <a:schemeClr val="tx1">
+                  <a:lumMod val="65000"/>
+                  <a:lumOff val="35000"/>
+                </a:schemeClr>
+              </a:solidFill>
+            </a:endParaRPr>
+          </a:p>
+        </p:txBody>
+      </p:sp>
     </p:spTree>
   </p:cSld>
   <p:clrMapOvr>
@@ -427,9 +601,9 @@
                 <a:solidFill>
                   <a:srgbClr val="FFFFFF"/>
                 </a:solidFill>
-                <a:latin typeface="Segoe UI"/>
-                <a:ea typeface="Segoe UI"/>
-                <a:cs typeface="Segoe UI"/>
+                <a:latin typeface="Segoe UI" panose="020B0502040204020203"/>
+                <a:ea typeface="Segoe UI" panose="020B0502040204020203"/>
+                <a:cs typeface="Segoe UI" panose="020B0502040204020203"/>
               </a:rPr>
               <a:t>его биография</a:t>
             </a:r>
@@ -476,9 +650,9 @@
                 <a:solidFill>
                   <a:srgbClr val="202124"/>
                 </a:solidFill>
-                <a:latin typeface="Segoe UI"/>
-                <a:ea typeface="Segoe UI"/>
-                <a:cs typeface="Segoe UI"/>
+                <a:latin typeface="Segoe UI" panose="020B0502040204020203"/>
+                <a:ea typeface="Segoe UI" panose="020B0502040204020203"/>
+                <a:cs typeface="Segoe UI" panose="020B0502040204020203"/>
               </a:rPr>
               <a:t>Путь Карла Линнея</a:t>
             </a:r>
@@ -520,8 +694,8 @@
           <p:nvPr/>
         </p:nvPicPr>
         <p:blipFill>
-          <a:blip r:embed="rId2"/>
-          <a:srcRect l="716" t="0" r="716" b="0"/>
+          <a:blip r:embed="rId1"/>
+          <a:srcRect l="716" r="716"/>
           <a:stretch>
             <a:fillRect/>
           </a:stretch>
@@ -629,9 +803,9 @@
                 <a:solidFill>
                   <a:srgbClr val="202124"/>
                 </a:solidFill>
-                <a:latin typeface="Segoe UI"/>
-                <a:ea typeface="Segoe UI"/>
-                <a:cs typeface="Segoe UI"/>
+                <a:latin typeface="Segoe UI" panose="020B0502040204020203"/>
+                <a:ea typeface="Segoe UI" panose="020B0502040204020203"/>
+                <a:cs typeface="Segoe UI" panose="020B0502040204020203"/>
               </a:rPr>
               <a:t>Родился 23 мая 1707 года в Швеции, в семье пастора.</a:t>
             </a:r>
@@ -729,9 +903,9 @@
                 <a:solidFill>
                   <a:srgbClr val="202124"/>
                 </a:solidFill>
-                <a:latin typeface="Segoe UI"/>
-                <a:ea typeface="Segoe UI"/>
-                <a:cs typeface="Segoe UI"/>
+                <a:latin typeface="Segoe UI" panose="020B0502040204020203"/>
+                <a:ea typeface="Segoe UI" panose="020B0502040204020203"/>
+                <a:cs typeface="Segoe UI" panose="020B0502040204020203"/>
               </a:rPr>
               <a:t>С детства любил растения, его звали «маленький ботаник».</a:t>
             </a:r>
@@ -829,9 +1003,9 @@
                 <a:solidFill>
                   <a:srgbClr val="202124"/>
                 </a:solidFill>
-                <a:latin typeface="Segoe UI"/>
-                <a:ea typeface="Segoe UI"/>
-                <a:cs typeface="Segoe UI"/>
+                <a:latin typeface="Segoe UI" panose="020B0502040204020203"/>
+                <a:ea typeface="Segoe UI" panose="020B0502040204020203"/>
+                <a:cs typeface="Segoe UI" panose="020B0502040204020203"/>
               </a:rPr>
               <a:t>Учился на врача и ботаника в Лунде и Упсале.</a:t>
             </a:r>
@@ -929,9 +1103,9 @@
                 <a:solidFill>
                   <a:srgbClr val="202124"/>
                 </a:solidFill>
-                <a:latin typeface="Segoe UI"/>
-                <a:ea typeface="Segoe UI"/>
-                <a:cs typeface="Segoe UI"/>
+                <a:latin typeface="Segoe UI" panose="020B0502040204020203"/>
+                <a:ea typeface="Segoe UI" panose="020B0502040204020203"/>
+                <a:cs typeface="Segoe UI" panose="020B0502040204020203"/>
               </a:rPr>
               <a:t>В 1735 году стал доктором медицины в Голландии.</a:t>
             </a:r>
@@ -1035,9 +1209,9 @@
                 <a:solidFill>
                   <a:srgbClr val="FFFFFF"/>
                 </a:solidFill>
-                <a:latin typeface="Segoe UI"/>
-                <a:ea typeface="Segoe UI"/>
-                <a:cs typeface="Segoe UI"/>
+                <a:latin typeface="Segoe UI" panose="020B0502040204020203"/>
+                <a:ea typeface="Segoe UI" panose="020B0502040204020203"/>
+                <a:cs typeface="Segoe UI" panose="020B0502040204020203"/>
               </a:rPr>
               <a:t>главное открытие</a:t>
             </a:r>
@@ -1084,9 +1258,9 @@
                 <a:solidFill>
                   <a:srgbClr val="202124"/>
                 </a:solidFill>
-                <a:latin typeface="Segoe UI"/>
-                <a:ea typeface="Segoe UI"/>
-                <a:cs typeface="Segoe UI"/>
+                <a:latin typeface="Segoe UI" panose="020B0502040204020203"/>
+                <a:ea typeface="Segoe UI" panose="020B0502040204020203"/>
+                <a:cs typeface="Segoe UI" panose="020B0502040204020203"/>
               </a:rPr>
               <a:t>Двойные названия</a:t>
             </a:r>
@@ -1133,9 +1307,9 @@
                 <a:solidFill>
                   <a:srgbClr val="5F6368"/>
                 </a:solidFill>
-                <a:latin typeface="Segoe UI"/>
-                <a:ea typeface="Segoe UI"/>
-                <a:cs typeface="Segoe UI"/>
+                <a:latin typeface="Segoe UI" panose="020B0502040204020203"/>
+                <a:ea typeface="Segoe UI" panose="020B0502040204020203"/>
+                <a:cs typeface="Segoe UI" panose="020B0502040204020203"/>
               </a:rPr>
               <a:t>Линней дал каждому виду </a:t>
             </a:r>
@@ -1144,9 +1318,9 @@
                 <a:solidFill>
                   <a:srgbClr val="202124"/>
                 </a:solidFill>
-                <a:latin typeface="Segoe UI"/>
-                <a:ea typeface="Segoe UI"/>
-                <a:cs typeface="Segoe UI"/>
+                <a:latin typeface="Segoe UI" panose="020B0502040204020203"/>
+                <a:ea typeface="Segoe UI" panose="020B0502040204020203"/>
+                <a:cs typeface="Segoe UI" panose="020B0502040204020203"/>
               </a:rPr>
               <a:t>два слова</a:t>
             </a:r>
@@ -1155,9 +1329,9 @@
                 <a:solidFill>
                   <a:srgbClr val="5F6368"/>
                 </a:solidFill>
-                <a:latin typeface="Segoe UI"/>
-                <a:ea typeface="Segoe UI"/>
-                <a:cs typeface="Segoe UI"/>
+                <a:latin typeface="Segoe UI" panose="020B0502040204020203"/>
+                <a:ea typeface="Segoe UI" panose="020B0502040204020203"/>
+                <a:cs typeface="Segoe UI" panose="020B0502040204020203"/>
               </a:rPr>
               <a:t>: сначала род, потом вид. Теперь учёные всех стран понимают друг</a:t>
             </a:r>
@@ -1169,9 +1343,9 @@
                 <a:solidFill>
                   <a:srgbClr val="5F6368"/>
                 </a:solidFill>
-                <a:latin typeface="Segoe UI"/>
-                <a:ea typeface="Segoe UI"/>
-                <a:cs typeface="Segoe UI"/>
+                <a:latin typeface="Segoe UI" panose="020B0502040204020203"/>
+                <a:ea typeface="Segoe UI" panose="020B0502040204020203"/>
+                <a:cs typeface="Segoe UI" panose="020B0502040204020203"/>
               </a:rPr>
               <a:t>друга.</a:t>
             </a:r>
@@ -1245,9 +1419,9 @@
                 <a:solidFill>
                   <a:srgbClr val="1A73E8"/>
                 </a:solidFill>
-                <a:latin typeface="Segoe UI"/>
-                <a:ea typeface="Segoe UI"/>
-                <a:cs typeface="Segoe UI"/>
+                <a:latin typeface="Segoe UI" panose="020B0502040204020203"/>
+                <a:ea typeface="Segoe UI" panose="020B0502040204020203"/>
+                <a:cs typeface="Segoe UI" panose="020B0502040204020203"/>
               </a:rPr>
               <a:t>Felis catus</a:t>
             </a:r>
@@ -1294,9 +1468,9 @@
                 <a:solidFill>
                   <a:srgbClr val="202124"/>
                 </a:solidFill>
-                <a:latin typeface="Segoe UI"/>
-                <a:ea typeface="Segoe UI"/>
-                <a:cs typeface="Segoe UI"/>
+                <a:latin typeface="Segoe UI" panose="020B0502040204020203"/>
+                <a:ea typeface="Segoe UI" panose="020B0502040204020203"/>
+                <a:cs typeface="Segoe UI" panose="020B0502040204020203"/>
               </a:rPr>
               <a:t>домашняя кошка</a:t>
             </a:r>
@@ -1370,9 +1544,9 @@
                 <a:solidFill>
                   <a:srgbClr val="EA4335"/>
                 </a:solidFill>
-                <a:latin typeface="Segoe UI"/>
-                <a:ea typeface="Segoe UI"/>
-                <a:cs typeface="Segoe UI"/>
+                <a:latin typeface="Segoe UI" panose="020B0502040204020203"/>
+                <a:ea typeface="Segoe UI" panose="020B0502040204020203"/>
+                <a:cs typeface="Segoe UI" panose="020B0502040204020203"/>
               </a:rPr>
               <a:t>Rosa canina</a:t>
             </a:r>
@@ -1419,9 +1593,9 @@
                 <a:solidFill>
                   <a:srgbClr val="202124"/>
                 </a:solidFill>
-                <a:latin typeface="Segoe UI"/>
-                <a:ea typeface="Segoe UI"/>
-                <a:cs typeface="Segoe UI"/>
+                <a:latin typeface="Segoe UI" panose="020B0502040204020203"/>
+                <a:ea typeface="Segoe UI" panose="020B0502040204020203"/>
+                <a:cs typeface="Segoe UI" panose="020B0502040204020203"/>
               </a:rPr>
               <a:t>шиповник</a:t>
             </a:r>
@@ -1495,9 +1669,9 @@
                 <a:solidFill>
                   <a:srgbClr val="34A853"/>
                 </a:solidFill>
-                <a:latin typeface="Segoe UI"/>
-                <a:ea typeface="Segoe UI"/>
-                <a:cs typeface="Segoe UI"/>
+                <a:latin typeface="Segoe UI" panose="020B0502040204020203"/>
+                <a:ea typeface="Segoe UI" panose="020B0502040204020203"/>
+                <a:cs typeface="Segoe UI" panose="020B0502040204020203"/>
               </a:rPr>
               <a:t>Homo sapiens</a:t>
             </a:r>
@@ -1544,9 +1718,9 @@
                 <a:solidFill>
                   <a:srgbClr val="202124"/>
                 </a:solidFill>
-                <a:latin typeface="Segoe UI"/>
-                <a:ea typeface="Segoe UI"/>
-                <a:cs typeface="Segoe UI"/>
+                <a:latin typeface="Segoe UI" panose="020B0502040204020203"/>
+                <a:ea typeface="Segoe UI" panose="020B0502040204020203"/>
+                <a:cs typeface="Segoe UI" panose="020B0502040204020203"/>
               </a:rPr>
               <a:t>человек разумный</a:t>
             </a:r>
@@ -1650,9 +1824,9 @@
                 <a:solidFill>
                   <a:srgbClr val="FFFFFF"/>
                 </a:solidFill>
-                <a:latin typeface="Segoe UI"/>
-                <a:ea typeface="Segoe UI"/>
-                <a:cs typeface="Segoe UI"/>
+                <a:latin typeface="Segoe UI" panose="020B0502040204020203"/>
+                <a:ea typeface="Segoe UI" panose="020B0502040204020203"/>
+                <a:cs typeface="Segoe UI" panose="020B0502040204020203"/>
               </a:rPr>
               <a:t>как это устроено</a:t>
             </a:r>
@@ -1699,9 +1873,9 @@
                 <a:solidFill>
                   <a:srgbClr val="202124"/>
                 </a:solidFill>
-                <a:latin typeface="Segoe UI"/>
-                <a:ea typeface="Segoe UI"/>
-                <a:cs typeface="Segoe UI"/>
+                <a:latin typeface="Segoe UI" panose="020B0502040204020203"/>
+                <a:ea typeface="Segoe UI" panose="020B0502040204020203"/>
+                <a:cs typeface="Segoe UI" panose="020B0502040204020203"/>
               </a:rPr>
               <a:t>Лестница живого мира</a:t>
             </a:r>
@@ -1748,9 +1922,9 @@
                 <a:solidFill>
                   <a:srgbClr val="5F6368"/>
                 </a:solidFill>
-                <a:latin typeface="Segoe UI"/>
-                <a:ea typeface="Segoe UI"/>
-                <a:cs typeface="Segoe UI"/>
+                <a:latin typeface="Segoe UI" panose="020B0502040204020203"/>
+                <a:ea typeface="Segoe UI" panose="020B0502040204020203"/>
+                <a:cs typeface="Segoe UI" panose="020B0502040204020203"/>
               </a:rPr>
               <a:t>Живой мир Линней расположил по группам одна внутри другой — как матрёшки.</a:t>
             </a:r>
@@ -1848,9 +2022,9 @@
                 <a:solidFill>
                   <a:srgbClr val="FFFFFF"/>
                 </a:solidFill>
-                <a:latin typeface="Segoe UI"/>
-                <a:ea typeface="Segoe UI"/>
-                <a:cs typeface="Segoe UI"/>
+                <a:latin typeface="Segoe UI" panose="020B0502040204020203"/>
+                <a:ea typeface="Segoe UI" panose="020B0502040204020203"/>
+                <a:cs typeface="Segoe UI" panose="020B0502040204020203"/>
               </a:rPr>
               <a:t>класс</a:t>
             </a:r>
@@ -1897,9 +2071,9 @@
                 <a:solidFill>
                   <a:srgbClr val="202124"/>
                 </a:solidFill>
-                <a:latin typeface="Segoe UI"/>
-                <a:ea typeface="Segoe UI"/>
-                <a:cs typeface="Segoe UI"/>
+                <a:latin typeface="Segoe UI" panose="020B0502040204020203"/>
+                <a:ea typeface="Segoe UI" panose="020B0502040204020203"/>
+                <a:cs typeface="Segoe UI" panose="020B0502040204020203"/>
               </a:rPr>
               <a:t>самая большая группа похожих существ</a:t>
             </a:r>
@@ -1997,9 +2171,9 @@
                 <a:solidFill>
                   <a:srgbClr val="FFFFFF"/>
                 </a:solidFill>
-                <a:latin typeface="Segoe UI"/>
-                <a:ea typeface="Segoe UI"/>
-                <a:cs typeface="Segoe UI"/>
+                <a:latin typeface="Segoe UI" panose="020B0502040204020203"/>
+                <a:ea typeface="Segoe UI" panose="020B0502040204020203"/>
+                <a:cs typeface="Segoe UI" panose="020B0502040204020203"/>
               </a:rPr>
               <a:t>отряд / порядок</a:t>
             </a:r>
@@ -2046,9 +2220,9 @@
                 <a:solidFill>
                   <a:srgbClr val="202124"/>
                 </a:solidFill>
-                <a:latin typeface="Segoe UI"/>
-                <a:ea typeface="Segoe UI"/>
-                <a:cs typeface="Segoe UI"/>
+                <a:latin typeface="Segoe UI" panose="020B0502040204020203"/>
+                <a:ea typeface="Segoe UI" panose="020B0502040204020203"/>
+                <a:cs typeface="Segoe UI" panose="020B0502040204020203"/>
               </a:rPr>
               <a:t>поменьше, внутри класса</a:t>
             </a:r>
@@ -2146,9 +2320,9 @@
                 <a:solidFill>
                   <a:srgbClr val="202124"/>
                 </a:solidFill>
-                <a:latin typeface="Segoe UI"/>
-                <a:ea typeface="Segoe UI"/>
-                <a:cs typeface="Segoe UI"/>
+                <a:latin typeface="Segoe UI" panose="020B0502040204020203"/>
+                <a:ea typeface="Segoe UI" panose="020B0502040204020203"/>
+                <a:cs typeface="Segoe UI" panose="020B0502040204020203"/>
               </a:rPr>
               <a:t>род</a:t>
             </a:r>
@@ -2195,9 +2369,9 @@
                 <a:solidFill>
                   <a:srgbClr val="202124"/>
                 </a:solidFill>
-                <a:latin typeface="Segoe UI"/>
-                <a:ea typeface="Segoe UI"/>
-                <a:cs typeface="Segoe UI"/>
+                <a:latin typeface="Segoe UI" panose="020B0502040204020203"/>
+                <a:ea typeface="Segoe UI" panose="020B0502040204020203"/>
+                <a:cs typeface="Segoe UI" panose="020B0502040204020203"/>
               </a:rPr>
               <a:t>очень похожие друг на друга</a:t>
             </a:r>
@@ -2295,9 +2469,9 @@
                 <a:solidFill>
                   <a:srgbClr val="FFFFFF"/>
                 </a:solidFill>
-                <a:latin typeface="Segoe UI"/>
-                <a:ea typeface="Segoe UI"/>
-                <a:cs typeface="Segoe UI"/>
+                <a:latin typeface="Segoe UI" panose="020B0502040204020203"/>
+                <a:ea typeface="Segoe UI" panose="020B0502040204020203"/>
+                <a:cs typeface="Segoe UI" panose="020B0502040204020203"/>
               </a:rPr>
               <a:t>вид</a:t>
             </a:r>
@@ -2344,9 +2518,9 @@
                 <a:solidFill>
                   <a:srgbClr val="202124"/>
                 </a:solidFill>
-                <a:latin typeface="Segoe UI"/>
-                <a:ea typeface="Segoe UI"/>
-                <a:cs typeface="Segoe UI"/>
+                <a:latin typeface="Segoe UI" panose="020B0502040204020203"/>
+                <a:ea typeface="Segoe UI" panose="020B0502040204020203"/>
+                <a:cs typeface="Segoe UI" panose="020B0502040204020203"/>
               </a:rPr>
               <a:t>самая маленькая группа — одно существо</a:t>
             </a:r>
@@ -2450,9 +2624,9 @@
                 <a:solidFill>
                   <a:srgbClr val="202124"/>
                 </a:solidFill>
-                <a:latin typeface="Segoe UI"/>
-                <a:ea typeface="Segoe UI"/>
-                <a:cs typeface="Segoe UI"/>
+                <a:latin typeface="Segoe UI" panose="020B0502040204020203"/>
+                <a:ea typeface="Segoe UI" panose="020B0502040204020203"/>
+                <a:cs typeface="Segoe UI" panose="020B0502040204020203"/>
               </a:rPr>
               <a:t>интересные факты</a:t>
             </a:r>
@@ -2499,9 +2673,9 @@
                 <a:solidFill>
                   <a:srgbClr val="202124"/>
                 </a:solidFill>
-                <a:latin typeface="Segoe UI"/>
-                <a:ea typeface="Segoe UI"/>
-                <a:cs typeface="Segoe UI"/>
+                <a:latin typeface="Segoe UI" panose="020B0502040204020203"/>
+                <a:ea typeface="Segoe UI" panose="020B0502040204020203"/>
+                <a:cs typeface="Segoe UI" panose="020B0502040204020203"/>
               </a:rPr>
               <a:t>Знаешь ли ты?</a:t>
             </a:r>
@@ -2599,9 +2773,9 @@
                 <a:solidFill>
                   <a:srgbClr val="202124"/>
                 </a:solidFill>
-                <a:latin typeface="Segoe UI"/>
-                <a:ea typeface="Segoe UI"/>
-                <a:cs typeface="Segoe UI"/>
+                <a:latin typeface="Segoe UI" panose="020B0502040204020203"/>
+                <a:ea typeface="Segoe UI" panose="020B0502040204020203"/>
+                <a:cs typeface="Segoe UI" panose="020B0502040204020203"/>
               </a:rPr>
               <a:t>Линней назвал человека Homo sapiens — «человек разумный».</a:t>
             </a:r>
@@ -2699,9 +2873,9 @@
                 <a:solidFill>
                   <a:srgbClr val="202124"/>
                 </a:solidFill>
-                <a:latin typeface="Segoe UI"/>
-                <a:ea typeface="Segoe UI"/>
-                <a:cs typeface="Segoe UI"/>
+                <a:latin typeface="Segoe UI" panose="020B0502040204020203"/>
+                <a:ea typeface="Segoe UI" panose="020B0502040204020203"/>
+                <a:cs typeface="Segoe UI" panose="020B0502040204020203"/>
               </a:rPr>
               <a:t>Книга «Система природы» (1735) описывает весь живой мир.</a:t>
             </a:r>
@@ -2799,9 +2973,9 @@
                 <a:solidFill>
                   <a:srgbClr val="202124"/>
                 </a:solidFill>
-                <a:latin typeface="Segoe UI"/>
-                <a:ea typeface="Segoe UI"/>
-                <a:cs typeface="Segoe UI"/>
+                <a:latin typeface="Segoe UI" panose="020B0502040204020203"/>
+                <a:ea typeface="Segoe UI" panose="020B0502040204020203"/>
+                <a:cs typeface="Segoe UI" panose="020B0502040204020203"/>
               </a:rPr>
               <a:t>«Виды растений» (1753) — описания всех известных растений.</a:t>
             </a:r>
@@ -2899,9 +3073,9 @@
                 <a:solidFill>
                   <a:srgbClr val="202124"/>
                 </a:solidFill>
-                <a:latin typeface="Segoe UI"/>
-                <a:ea typeface="Segoe UI"/>
-                <a:cs typeface="Segoe UI"/>
+                <a:latin typeface="Segoe UI" panose="020B0502040204020203"/>
+                <a:ea typeface="Segoe UI" panose="020B0502040204020203"/>
+                <a:cs typeface="Segoe UI" panose="020B0502040204020203"/>
               </a:rPr>
               <a:t>Символы ♂ и ♀ для мужского и женского придумал именно он.</a:t>
             </a:r>
@@ -3005,9 +3179,9 @@
                 <a:solidFill>
                   <a:srgbClr val="FFFFFF"/>
                 </a:solidFill>
-                <a:latin typeface="Segoe UI"/>
-                <a:ea typeface="Segoe UI"/>
-                <a:cs typeface="Segoe UI"/>
+                <a:latin typeface="Segoe UI" panose="020B0502040204020203"/>
+                <a:ea typeface="Segoe UI" panose="020B0502040204020203"/>
+                <a:cs typeface="Segoe UI" panose="020B0502040204020203"/>
               </a:rPr>
               <a:t>итог</a:t>
             </a:r>
@@ -3054,9 +3228,9 @@
                 <a:solidFill>
                   <a:srgbClr val="202124"/>
                 </a:solidFill>
-                <a:latin typeface="Segoe UI"/>
-                <a:ea typeface="Segoe UI"/>
-                <a:cs typeface="Segoe UI"/>
+                <a:latin typeface="Segoe UI" panose="020B0502040204020203"/>
+                <a:ea typeface="Segoe UI" panose="020B0502040204020203"/>
+                <a:cs typeface="Segoe UI" panose="020B0502040204020203"/>
               </a:rPr>
               <a:t>Спасибо</a:t>
             </a:r>
@@ -3068,9 +3242,9 @@
                 <a:solidFill>
                   <a:srgbClr val="202124"/>
                 </a:solidFill>
-                <a:latin typeface="Segoe UI"/>
-                <a:ea typeface="Segoe UI"/>
-                <a:cs typeface="Segoe UI"/>
+                <a:latin typeface="Segoe UI" panose="020B0502040204020203"/>
+                <a:ea typeface="Segoe UI" panose="020B0502040204020203"/>
+                <a:cs typeface="Segoe UI" panose="020B0502040204020203"/>
               </a:rPr>
               <a:t>за внимание!</a:t>
             </a:r>
@@ -3117,9 +3291,9 @@
                 <a:solidFill>
                   <a:srgbClr val="5F6368"/>
                 </a:solidFill>
-                <a:latin typeface="Segoe UI"/>
-                <a:ea typeface="Segoe UI"/>
-                <a:cs typeface="Segoe UI"/>
+                <a:latin typeface="Segoe UI" panose="020B0502040204020203"/>
+                <a:ea typeface="Segoe UI" panose="020B0502040204020203"/>
+                <a:cs typeface="Segoe UI" panose="020B0502040204020203"/>
               </a:rPr>
               <a:t>Систему Линнея используют учёные всего мира и по сей день.</a:t>
             </a:r>
@@ -3161,8 +3335,8 @@
           <p:nvPr/>
         </p:nvPicPr>
         <p:blipFill>
-          <a:blip r:embed="rId2"/>
-          <a:srcRect l="0" t="949" r="0" b="949"/>
+          <a:blip r:embed="rId1"/>
+          <a:srcRect t="949" b="949"/>
           <a:stretch>
             <a:fillRect/>
           </a:stretch>
@@ -3373,5 +3547,10 @@
       </a:bgFillStyleLst>
     </a:fmtScheme>
   </a:themeElements>
+  <a:extLst>
+    <a:ext uri="{05A4C25C-085E-4340-85A3-A5531E510DB2}">
+      <thm15:themeFamily xmlns:thm15="http://schemas.microsoft.com/office/thememl/2012/main" name="Office Theme" id="{62F939B6-93AF-4DB8-9C6B-D6C7DFDC589F}" vid="{4A3C46E8-61CC-4603-A589-7422A47A8E4A}"/>
+    </a:ext>
+  </a:extLst>
 </a:theme>
 </file>
</xml_diff>

<commit_message>
??????????: Karl-Linney-chistaya.pptx (??? ?????? ?? ??????? 1 ? 6)
</commit_message>
<xml_diff>
--- a/prezentacii/Karl-Linney-chistaya.pptx
+++ b/prezentacii/Karl-Linney-chistaya.pptx
@@ -1,6 +1,6 @@
 
 <file path=ppt/presentation.xml><?xml version="1.0" encoding="utf-8"?>
-<p:presentation xmlns:a="http://schemas.openxmlformats.org/drawingml/2006/main" xmlns:r="http://schemas.openxmlformats.org/officeDocument/2006/relationships" xmlns:p="http://schemas.openxmlformats.org/presentationml/2006/main">
+<p:presentation xmlns:a="http://schemas.openxmlformats.org/drawingml/2006/main" xmlns:r="http://schemas.openxmlformats.org/officeDocument/2006/relationships" xmlns:p="http://schemas.openxmlformats.org/presentationml/2006/main" saveSubsetFonts="1">
   <p:sldMasterIdLst>
     <p:sldMasterId id="2147483648" r:id="rId1"/>
   </p:sldMasterIdLst>
@@ -14,98 +14,6 @@
   </p:sldIdLst>
   <p:sldSz cx="12192000" cy="6858000"/>
   <p:notesSz cx="6858000" cy="9144000"/>
-  <p:defaultTextStyle>
-    <a:lvl1pPr marL="0" algn="l" defTabSz="914400" rtl="0" eaLnBrk="1" latinLnBrk="0" hangingPunct="1">
-      <a:defRPr sz="1800" kern="1200">
-        <a:solidFill>
-          <a:schemeClr val="tx1"/>
-        </a:solidFill>
-        <a:latin typeface="+mn-lt"/>
-        <a:ea typeface="+mn-ea"/>
-        <a:cs typeface="+mn-cs"/>
-      </a:defRPr>
-    </a:lvl1pPr>
-    <a:lvl2pPr marL="457200" algn="l" defTabSz="914400" rtl="0" eaLnBrk="1" latinLnBrk="0" hangingPunct="1">
-      <a:defRPr sz="1800" kern="1200">
-        <a:solidFill>
-          <a:schemeClr val="tx1"/>
-        </a:solidFill>
-        <a:latin typeface="+mn-lt"/>
-        <a:ea typeface="+mn-ea"/>
-        <a:cs typeface="+mn-cs"/>
-      </a:defRPr>
-    </a:lvl2pPr>
-    <a:lvl3pPr marL="914400" algn="l" defTabSz="914400" rtl="0" eaLnBrk="1" latinLnBrk="0" hangingPunct="1">
-      <a:defRPr sz="1800" kern="1200">
-        <a:solidFill>
-          <a:schemeClr val="tx1"/>
-        </a:solidFill>
-        <a:latin typeface="+mn-lt"/>
-        <a:ea typeface="+mn-ea"/>
-        <a:cs typeface="+mn-cs"/>
-      </a:defRPr>
-    </a:lvl3pPr>
-    <a:lvl4pPr marL="1371600" algn="l" defTabSz="914400" rtl="0" eaLnBrk="1" latinLnBrk="0" hangingPunct="1">
-      <a:defRPr sz="1800" kern="1200">
-        <a:solidFill>
-          <a:schemeClr val="tx1"/>
-        </a:solidFill>
-        <a:latin typeface="+mn-lt"/>
-        <a:ea typeface="+mn-ea"/>
-        <a:cs typeface="+mn-cs"/>
-      </a:defRPr>
-    </a:lvl4pPr>
-    <a:lvl5pPr marL="1828800" algn="l" defTabSz="914400" rtl="0" eaLnBrk="1" latinLnBrk="0" hangingPunct="1">
-      <a:defRPr sz="1800" kern="1200">
-        <a:solidFill>
-          <a:schemeClr val="tx1"/>
-        </a:solidFill>
-        <a:latin typeface="+mn-lt"/>
-        <a:ea typeface="+mn-ea"/>
-        <a:cs typeface="+mn-cs"/>
-      </a:defRPr>
-    </a:lvl5pPr>
-    <a:lvl6pPr marL="2286000" algn="l" defTabSz="914400" rtl="0" eaLnBrk="1" latinLnBrk="0" hangingPunct="1">
-      <a:defRPr sz="1800" kern="1200">
-        <a:solidFill>
-          <a:schemeClr val="tx1"/>
-        </a:solidFill>
-        <a:latin typeface="+mn-lt"/>
-        <a:ea typeface="+mn-ea"/>
-        <a:cs typeface="+mn-cs"/>
-      </a:defRPr>
-    </a:lvl6pPr>
-    <a:lvl7pPr marL="2743200" algn="l" defTabSz="914400" rtl="0" eaLnBrk="1" latinLnBrk="0" hangingPunct="1">
-      <a:defRPr sz="1800" kern="1200">
-        <a:solidFill>
-          <a:schemeClr val="tx1"/>
-        </a:solidFill>
-        <a:latin typeface="+mn-lt"/>
-        <a:ea typeface="+mn-ea"/>
-        <a:cs typeface="+mn-cs"/>
-      </a:defRPr>
-    </a:lvl7pPr>
-    <a:lvl8pPr marL="3200400" algn="l" defTabSz="914400" rtl="0" eaLnBrk="1" latinLnBrk="0" hangingPunct="1">
-      <a:defRPr sz="1800" kern="1200">
-        <a:solidFill>
-          <a:schemeClr val="tx1"/>
-        </a:solidFill>
-        <a:latin typeface="+mn-lt"/>
-        <a:ea typeface="+mn-ea"/>
-        <a:cs typeface="+mn-cs"/>
-      </a:defRPr>
-    </a:lvl8pPr>
-    <a:lvl9pPr marL="3657600" algn="l" defTabSz="914400" rtl="0" eaLnBrk="1" latinLnBrk="0" hangingPunct="1">
-      <a:defRPr sz="1800" kern="1200">
-        <a:solidFill>
-          <a:schemeClr val="tx1"/>
-        </a:solidFill>
-        <a:latin typeface="+mn-lt"/>
-        <a:ea typeface="+mn-ea"/>
-        <a:cs typeface="+mn-cs"/>
-      </a:defRPr>
-    </a:lvl9pPr>
-  </p:defaultTextStyle>
 </p:presentation>
 </file>
 
@@ -137,11 +45,6 @@
 <file path=ppt/slideMasters/slideMaster1.xml><?xml version="1.0" encoding="utf-8"?>
 <p:sldMaster xmlns:a="http://schemas.openxmlformats.org/drawingml/2006/main" xmlns:r="http://schemas.openxmlformats.org/officeDocument/2006/relationships" xmlns:p="http://schemas.openxmlformats.org/presentationml/2006/main">
   <p:cSld>
-    <p:bg>
-      <p:bgRef idx="1001">
-        <a:schemeClr val="bg1"/>
-      </p:bgRef>
-    </p:bg>
     <p:spTree>
       <p:nvGrpSpPr>
         <p:cNvPr id="1" name=""/>
@@ -162,11 +65,6 @@
   <p:sldLayoutIdLst>
     <p:sldLayoutId id="2147483649" r:id="rId1"/>
   </p:sldLayoutIdLst>
-  <p:txStyles>
-    <p:titleStyle/>
-    <p:bodyStyle/>
-    <p:otherStyle/>
-  </p:txStyles>
 </p:sldMaster>
 </file>
 
@@ -203,7 +101,7 @@
         </p:nvSpPr>
         <p:spPr>
           <a:xfrm>
-            <a:off x="762000" y="1134170"/>
+            <a:off x="762000" y="921445"/>
             <a:ext cx="1421011" cy="254000"/>
           </a:xfrm>
           <a:prstGeom prst="roundRect">
@@ -227,7 +125,7 @@
         </p:nvSpPr>
         <p:spPr>
           <a:xfrm>
-            <a:off x="876300" y="1172270"/>
+            <a:off x="876300" y="959545"/>
             <a:ext cx="1192411" cy="152400"/>
           </a:xfrm>
           <a:prstGeom prst="rect">
@@ -258,9 +156,9 @@
                 <a:solidFill>
                   <a:srgbClr val="FFFFFF"/>
                 </a:solidFill>
-                <a:latin typeface="Segoe UI" panose="020B0502040204020203"/>
-                <a:ea typeface="Segoe UI" panose="020B0502040204020203"/>
-                <a:cs typeface="Segoe UI" panose="020B0502040204020203"/>
+                <a:latin typeface="Segoe UI"/>
+                <a:ea typeface="Segoe UI"/>
+                <a:cs typeface="Segoe UI"/>
               </a:rPr>
               <a:t>биография · 1707–1778</a:t>
             </a:r>
@@ -276,7 +174,7 @@
         </p:nvSpPr>
         <p:spPr>
           <a:xfrm>
-            <a:off x="762000" y="1639689"/>
+            <a:off x="762000" y="1426964"/>
             <a:ext cx="5165626" cy="1173361"/>
           </a:xfrm>
           <a:prstGeom prst="rect">
@@ -307,9 +205,9 @@
                 <a:solidFill>
                   <a:srgbClr val="202124"/>
                 </a:solidFill>
-                <a:latin typeface="Segoe UI" panose="020B0502040204020203"/>
-                <a:ea typeface="Segoe UI" panose="020B0502040204020203"/>
-                <a:cs typeface="Segoe UI" panose="020B0502040204020203"/>
+                <a:latin typeface="Segoe UI"/>
+                <a:ea typeface="Segoe UI"/>
+                <a:cs typeface="Segoe UI"/>
               </a:rPr>
               <a:t>Карл Линней</a:t>
             </a:r>
@@ -321,9 +219,9 @@
                 <a:solidFill>
                   <a:srgbClr val="202124"/>
                 </a:solidFill>
-                <a:latin typeface="Segoe UI" panose="020B0502040204020203"/>
-                <a:ea typeface="Segoe UI" panose="020B0502040204020203"/>
-                <a:cs typeface="Segoe UI" panose="020B0502040204020203"/>
+                <a:latin typeface="Segoe UI"/>
+                <a:ea typeface="Segoe UI"/>
+                <a:cs typeface="Segoe UI"/>
               </a:rPr>
               <a:t>— отец систематики</a:t>
             </a:r>
@@ -339,7 +237,7 @@
         </p:nvSpPr>
         <p:spPr>
           <a:xfrm>
-            <a:off x="762000" y="2898080"/>
+            <a:off x="762000" y="2685355"/>
             <a:ext cx="5324673" cy="266700"/>
           </a:xfrm>
           <a:prstGeom prst="rect">
@@ -370,9 +268,9 @@
                 <a:solidFill>
                   <a:srgbClr val="5F6368"/>
                 </a:solidFill>
-                <a:latin typeface="Segoe UI" panose="020B0502040204020203"/>
-                <a:ea typeface="Segoe UI" panose="020B0502040204020203"/>
-                <a:cs typeface="Segoe UI" panose="020B0502040204020203"/>
+                <a:latin typeface="Segoe UI"/>
+                <a:ea typeface="Segoe UI"/>
+                <a:cs typeface="Segoe UI"/>
               </a:rPr>
               <a:t>Шведский учёный, который навёл порядок во всём живом мире.</a:t>
             </a:r>
@@ -382,14 +280,63 @@
       </p:sp>
       <p:sp>
         <p:nvSpPr>
-          <p:cNvPr id="6" name="Rounded Rectangle"/>
-          <p:cNvSpPr/>
-          <p:nvPr/>
-        </p:nvSpPr>
-        <p:spPr>
-          <a:xfrm>
-            <a:off x="7176135" y="548640"/>
-            <a:ext cx="4027805" cy="5123815"/>
+          <p:cNvPr id="6" name="Text: Выполнила: Самушенко Вероника, ученица 5"/>
+          <p:cNvSpPr txBox="1"/>
+          <p:nvPr/>
+        </p:nvSpPr>
+        <p:spPr>
+          <a:xfrm>
+            <a:off x="762000" y="3136205"/>
+            <a:ext cx="4008537" cy="247650"/>
+          </a:xfrm>
+          <a:prstGeom prst="rect">
+            <a:avLst/>
+          </a:prstGeom>
+          <a:noFill/>
+        </p:spPr>
+        <p:txBody>
+          <a:bodyPr wrap="none" lIns="0" tIns="0" rIns="0" bIns="0" rtlCol="0" anchor="t">
+            <a:noAutofit/>
+          </a:bodyPr>
+          <a:lstStyle/>
+          <a:p>
+            <a:pPr algn="l">
+              <a:lnSpc>
+                <a:spcPts val="1950"/>
+              </a:lnSpc>
+              <a:spcBef>
+                <a:spcPts val="0"/>
+              </a:spcBef>
+              <a:spcAft>
+                <a:spcPts val="0"/>
+              </a:spcAft>
+              <a:buNone/>
+            </a:pPr>
+            <a:r>
+              <a:rPr lang="en-US" sz="1300" spc="-4" dirty="0">
+                <a:solidFill>
+                  <a:srgbClr val="202124"/>
+                </a:solidFill>
+                <a:latin typeface="Segoe UI"/>
+                <a:ea typeface="Segoe UI"/>
+                <a:cs typeface="Segoe UI"/>
+              </a:rPr>
+              <a:t>Выполнила: Самушенко Вероника, ученица 5г класса</a:t>
+            </a:r>
+            <a:endParaRPr lang="en-US" sz="1300" dirty="0"/>
+          </a:p>
+        </p:txBody>
+      </p:sp>
+      <p:sp>
+        <p:nvSpPr>
+          <p:cNvPr id="7" name="Rounded Rectangle"/>
+          <p:cNvSpPr/>
+          <p:nvPr/>
+        </p:nvSpPr>
+        <p:spPr>
+          <a:xfrm>
+            <a:off x="765175" y="3577530"/>
+            <a:ext cx="1898650" cy="2355850"/>
           </a:xfrm>
           <a:prstGeom prst="roundRect">
             <a:avLst>
@@ -404,32 +351,26 @@
             <a:miter lim="800000"/>
           </a:ln>
         </p:spPr>
-        <p:txBody>
-          <a:bodyPr/>
-          <a:p>
-            <a:endParaRPr lang="ru-RU" altLang="en-US"/>
-          </a:p>
-        </p:txBody>
       </p:sp>
       <p:pic>
         <p:nvPicPr>
-          <p:cNvPr id="7" name="Image: Портрет Карла Линнея"/>
+          <p:cNvPr id="8" name="Image: Портрет Карла Линнея"/>
           <p:cNvPicPr>
             <a:picLocks noChangeAspect="1"/>
           </p:cNvPicPr>
           <p:nvPr/>
         </p:nvPicPr>
         <p:blipFill>
-          <a:blip r:embed="rId1"/>
-          <a:srcRect l="1046" r="1046"/>
+          <a:blip r:embed="rId2"/>
+          <a:srcRect l="1046" t="0" r="1046" b="0"/>
           <a:stretch>
             <a:fillRect/>
           </a:stretch>
         </p:blipFill>
         <p:spPr>
           <a:xfrm>
-            <a:off x="7176135" y="549275"/>
-            <a:ext cx="4028440" cy="5123180"/>
+            <a:off x="768350" y="3580705"/>
+            <a:ext cx="1892300" cy="2349500"/>
           </a:xfrm>
           <a:prstGeom prst="rect">
             <a:avLst/>
@@ -439,72 +380,6 @@
           </a:ln>
         </p:spPr>
       </p:pic>
-      <p:sp>
-        <p:nvSpPr>
-          <p:cNvPr id="12" name="Текстовое поле 11"/>
-          <p:cNvSpPr txBox="1"/>
-          <p:nvPr/>
-        </p:nvSpPr>
-        <p:spPr>
-          <a:xfrm>
-            <a:off x="695325" y="3184525"/>
-            <a:ext cx="4064000" cy="645160"/>
-          </a:xfrm>
-          <a:prstGeom prst="rect">
-            <a:avLst/>
-          </a:prstGeom>
-          <a:noFill/>
-        </p:spPr>
-        <p:txBody>
-          <a:bodyPr wrap="square" rtlCol="0">
-            <a:spAutoFit/>
-          </a:bodyPr>
-          <a:p>
-            <a:pPr algn="l"/>
-            <a:r>
-              <a:rPr lang="ru-RU" altLang="en-US">
-                <a:solidFill>
-                  <a:schemeClr val="tx1">
-                    <a:lumMod val="65000"/>
-                    <a:lumOff val="35000"/>
-                  </a:schemeClr>
-                </a:solidFill>
-              </a:rPr>
-              <a:t>Выполнила</a:t>
-            </a:r>
-            <a:r>
-              <a:rPr lang="en-US" altLang="en-US">
-                <a:solidFill>
-                  <a:schemeClr val="tx1">
-                    <a:lumMod val="65000"/>
-                    <a:lumOff val="35000"/>
-                  </a:schemeClr>
-                </a:solidFill>
-              </a:rPr>
-              <a:t>:</a:t>
-            </a:r>
-            <a:r>
-              <a:rPr lang="ru-RU" altLang="en-US">
-                <a:solidFill>
-                  <a:schemeClr val="tx1">
-                    <a:lumMod val="65000"/>
-                    <a:lumOff val="35000"/>
-                  </a:schemeClr>
-                </a:solidFill>
-              </a:rPr>
-              <a:t> Самущенко Вероника ученица 5Г класса</a:t>
-            </a:r>
-            <a:endParaRPr lang="ru-RU" altLang="en-US">
-              <a:solidFill>
-                <a:schemeClr val="tx1">
-                  <a:lumMod val="65000"/>
-                  <a:lumOff val="35000"/>
-                </a:schemeClr>
-              </a:solidFill>
-            </a:endParaRPr>
-          </a:p>
-        </p:txBody>
-      </p:sp>
     </p:spTree>
   </p:cSld>
   <p:clrMapOvr>
@@ -601,9 +476,9 @@
                 <a:solidFill>
                   <a:srgbClr val="FFFFFF"/>
                 </a:solidFill>
-                <a:latin typeface="Segoe UI" panose="020B0502040204020203"/>
-                <a:ea typeface="Segoe UI" panose="020B0502040204020203"/>
-                <a:cs typeface="Segoe UI" panose="020B0502040204020203"/>
+                <a:latin typeface="Segoe UI"/>
+                <a:ea typeface="Segoe UI"/>
+                <a:cs typeface="Segoe UI"/>
               </a:rPr>
               <a:t>его биография</a:t>
             </a:r>
@@ -650,9 +525,9 @@
                 <a:solidFill>
                   <a:srgbClr val="202124"/>
                 </a:solidFill>
-                <a:latin typeface="Segoe UI" panose="020B0502040204020203"/>
-                <a:ea typeface="Segoe UI" panose="020B0502040204020203"/>
-                <a:cs typeface="Segoe UI" panose="020B0502040204020203"/>
+                <a:latin typeface="Segoe UI"/>
+                <a:ea typeface="Segoe UI"/>
+                <a:cs typeface="Segoe UI"/>
               </a:rPr>
               <a:t>Путь Карла Линнея</a:t>
             </a:r>
@@ -694,8 +569,8 @@
           <p:nvPr/>
         </p:nvPicPr>
         <p:blipFill>
-          <a:blip r:embed="rId1"/>
-          <a:srcRect l="716" r="716"/>
+          <a:blip r:embed="rId2"/>
+          <a:srcRect l="716" t="0" r="716" b="0"/>
           <a:stretch>
             <a:fillRect/>
           </a:stretch>
@@ -803,9 +678,9 @@
                 <a:solidFill>
                   <a:srgbClr val="202124"/>
                 </a:solidFill>
-                <a:latin typeface="Segoe UI" panose="020B0502040204020203"/>
-                <a:ea typeface="Segoe UI" panose="020B0502040204020203"/>
-                <a:cs typeface="Segoe UI" panose="020B0502040204020203"/>
+                <a:latin typeface="Segoe UI"/>
+                <a:ea typeface="Segoe UI"/>
+                <a:cs typeface="Segoe UI"/>
               </a:rPr>
               <a:t>Родился 23 мая 1707 года в Швеции, в семье пастора.</a:t>
             </a:r>
@@ -903,9 +778,9 @@
                 <a:solidFill>
                   <a:srgbClr val="202124"/>
                 </a:solidFill>
-                <a:latin typeface="Segoe UI" panose="020B0502040204020203"/>
-                <a:ea typeface="Segoe UI" panose="020B0502040204020203"/>
-                <a:cs typeface="Segoe UI" panose="020B0502040204020203"/>
+                <a:latin typeface="Segoe UI"/>
+                <a:ea typeface="Segoe UI"/>
+                <a:cs typeface="Segoe UI"/>
               </a:rPr>
               <a:t>С детства любил растения, его звали «маленький ботаник».</a:t>
             </a:r>
@@ -1003,9 +878,9 @@
                 <a:solidFill>
                   <a:srgbClr val="202124"/>
                 </a:solidFill>
-                <a:latin typeface="Segoe UI" panose="020B0502040204020203"/>
-                <a:ea typeface="Segoe UI" panose="020B0502040204020203"/>
-                <a:cs typeface="Segoe UI" panose="020B0502040204020203"/>
+                <a:latin typeface="Segoe UI"/>
+                <a:ea typeface="Segoe UI"/>
+                <a:cs typeface="Segoe UI"/>
               </a:rPr>
               <a:t>Учился на врача и ботаника в Лунде и Упсале.</a:t>
             </a:r>
@@ -1103,9 +978,9 @@
                 <a:solidFill>
                   <a:srgbClr val="202124"/>
                 </a:solidFill>
-                <a:latin typeface="Segoe UI" panose="020B0502040204020203"/>
-                <a:ea typeface="Segoe UI" panose="020B0502040204020203"/>
-                <a:cs typeface="Segoe UI" panose="020B0502040204020203"/>
+                <a:latin typeface="Segoe UI"/>
+                <a:ea typeface="Segoe UI"/>
+                <a:cs typeface="Segoe UI"/>
               </a:rPr>
               <a:t>В 1735 году стал доктором медицины в Голландии.</a:t>
             </a:r>
@@ -1209,9 +1084,9 @@
                 <a:solidFill>
                   <a:srgbClr val="FFFFFF"/>
                 </a:solidFill>
-                <a:latin typeface="Segoe UI" panose="020B0502040204020203"/>
-                <a:ea typeface="Segoe UI" panose="020B0502040204020203"/>
-                <a:cs typeface="Segoe UI" panose="020B0502040204020203"/>
+                <a:latin typeface="Segoe UI"/>
+                <a:ea typeface="Segoe UI"/>
+                <a:cs typeface="Segoe UI"/>
               </a:rPr>
               <a:t>главное открытие</a:t>
             </a:r>
@@ -1258,9 +1133,9 @@
                 <a:solidFill>
                   <a:srgbClr val="202124"/>
                 </a:solidFill>
-                <a:latin typeface="Segoe UI" panose="020B0502040204020203"/>
-                <a:ea typeface="Segoe UI" panose="020B0502040204020203"/>
-                <a:cs typeface="Segoe UI" panose="020B0502040204020203"/>
+                <a:latin typeface="Segoe UI"/>
+                <a:ea typeface="Segoe UI"/>
+                <a:cs typeface="Segoe UI"/>
               </a:rPr>
               <a:t>Двойные названия</a:t>
             </a:r>
@@ -1307,9 +1182,9 @@
                 <a:solidFill>
                   <a:srgbClr val="5F6368"/>
                 </a:solidFill>
-                <a:latin typeface="Segoe UI" panose="020B0502040204020203"/>
-                <a:ea typeface="Segoe UI" panose="020B0502040204020203"/>
-                <a:cs typeface="Segoe UI" panose="020B0502040204020203"/>
+                <a:latin typeface="Segoe UI"/>
+                <a:ea typeface="Segoe UI"/>
+                <a:cs typeface="Segoe UI"/>
               </a:rPr>
               <a:t>Линней дал каждому виду </a:t>
             </a:r>
@@ -1318,9 +1193,9 @@
                 <a:solidFill>
                   <a:srgbClr val="202124"/>
                 </a:solidFill>
-                <a:latin typeface="Segoe UI" panose="020B0502040204020203"/>
-                <a:ea typeface="Segoe UI" panose="020B0502040204020203"/>
-                <a:cs typeface="Segoe UI" panose="020B0502040204020203"/>
+                <a:latin typeface="Segoe UI"/>
+                <a:ea typeface="Segoe UI"/>
+                <a:cs typeface="Segoe UI"/>
               </a:rPr>
               <a:t>два слова</a:t>
             </a:r>
@@ -1329,9 +1204,9 @@
                 <a:solidFill>
                   <a:srgbClr val="5F6368"/>
                 </a:solidFill>
-                <a:latin typeface="Segoe UI" panose="020B0502040204020203"/>
-                <a:ea typeface="Segoe UI" panose="020B0502040204020203"/>
-                <a:cs typeface="Segoe UI" panose="020B0502040204020203"/>
+                <a:latin typeface="Segoe UI"/>
+                <a:ea typeface="Segoe UI"/>
+                <a:cs typeface="Segoe UI"/>
               </a:rPr>
               <a:t>: сначала род, потом вид. Теперь учёные всех стран понимают друг</a:t>
             </a:r>
@@ -1343,9 +1218,9 @@
                 <a:solidFill>
                   <a:srgbClr val="5F6368"/>
                 </a:solidFill>
-                <a:latin typeface="Segoe UI" panose="020B0502040204020203"/>
-                <a:ea typeface="Segoe UI" panose="020B0502040204020203"/>
-                <a:cs typeface="Segoe UI" panose="020B0502040204020203"/>
+                <a:latin typeface="Segoe UI"/>
+                <a:ea typeface="Segoe UI"/>
+                <a:cs typeface="Segoe UI"/>
               </a:rPr>
               <a:t>друга.</a:t>
             </a:r>
@@ -1419,9 +1294,9 @@
                 <a:solidFill>
                   <a:srgbClr val="1A73E8"/>
                 </a:solidFill>
-                <a:latin typeface="Segoe UI" panose="020B0502040204020203"/>
-                <a:ea typeface="Segoe UI" panose="020B0502040204020203"/>
-                <a:cs typeface="Segoe UI" panose="020B0502040204020203"/>
+                <a:latin typeface="Segoe UI"/>
+                <a:ea typeface="Segoe UI"/>
+                <a:cs typeface="Segoe UI"/>
               </a:rPr>
               <a:t>Felis catus</a:t>
             </a:r>
@@ -1468,9 +1343,9 @@
                 <a:solidFill>
                   <a:srgbClr val="202124"/>
                 </a:solidFill>
-                <a:latin typeface="Segoe UI" panose="020B0502040204020203"/>
-                <a:ea typeface="Segoe UI" panose="020B0502040204020203"/>
-                <a:cs typeface="Segoe UI" panose="020B0502040204020203"/>
+                <a:latin typeface="Segoe UI"/>
+                <a:ea typeface="Segoe UI"/>
+                <a:cs typeface="Segoe UI"/>
               </a:rPr>
               <a:t>домашняя кошка</a:t>
             </a:r>
@@ -1544,9 +1419,9 @@
                 <a:solidFill>
                   <a:srgbClr val="EA4335"/>
                 </a:solidFill>
-                <a:latin typeface="Segoe UI" panose="020B0502040204020203"/>
-                <a:ea typeface="Segoe UI" panose="020B0502040204020203"/>
-                <a:cs typeface="Segoe UI" panose="020B0502040204020203"/>
+                <a:latin typeface="Segoe UI"/>
+                <a:ea typeface="Segoe UI"/>
+                <a:cs typeface="Segoe UI"/>
               </a:rPr>
               <a:t>Rosa canina</a:t>
             </a:r>
@@ -1593,9 +1468,9 @@
                 <a:solidFill>
                   <a:srgbClr val="202124"/>
                 </a:solidFill>
-                <a:latin typeface="Segoe UI" panose="020B0502040204020203"/>
-                <a:ea typeface="Segoe UI" panose="020B0502040204020203"/>
-                <a:cs typeface="Segoe UI" panose="020B0502040204020203"/>
+                <a:latin typeface="Segoe UI"/>
+                <a:ea typeface="Segoe UI"/>
+                <a:cs typeface="Segoe UI"/>
               </a:rPr>
               <a:t>шиповник</a:t>
             </a:r>
@@ -1669,9 +1544,9 @@
                 <a:solidFill>
                   <a:srgbClr val="34A853"/>
                 </a:solidFill>
-                <a:latin typeface="Segoe UI" panose="020B0502040204020203"/>
-                <a:ea typeface="Segoe UI" panose="020B0502040204020203"/>
-                <a:cs typeface="Segoe UI" panose="020B0502040204020203"/>
+                <a:latin typeface="Segoe UI"/>
+                <a:ea typeface="Segoe UI"/>
+                <a:cs typeface="Segoe UI"/>
               </a:rPr>
               <a:t>Homo sapiens</a:t>
             </a:r>
@@ -1718,9 +1593,9 @@
                 <a:solidFill>
                   <a:srgbClr val="202124"/>
                 </a:solidFill>
-                <a:latin typeface="Segoe UI" panose="020B0502040204020203"/>
-                <a:ea typeface="Segoe UI" panose="020B0502040204020203"/>
-                <a:cs typeface="Segoe UI" panose="020B0502040204020203"/>
+                <a:latin typeface="Segoe UI"/>
+                <a:ea typeface="Segoe UI"/>
+                <a:cs typeface="Segoe UI"/>
               </a:rPr>
               <a:t>человек разумный</a:t>
             </a:r>
@@ -1824,9 +1699,9 @@
                 <a:solidFill>
                   <a:srgbClr val="FFFFFF"/>
                 </a:solidFill>
-                <a:latin typeface="Segoe UI" panose="020B0502040204020203"/>
-                <a:ea typeface="Segoe UI" panose="020B0502040204020203"/>
-                <a:cs typeface="Segoe UI" panose="020B0502040204020203"/>
+                <a:latin typeface="Segoe UI"/>
+                <a:ea typeface="Segoe UI"/>
+                <a:cs typeface="Segoe UI"/>
               </a:rPr>
               <a:t>как это устроено</a:t>
             </a:r>
@@ -1873,9 +1748,9 @@
                 <a:solidFill>
                   <a:srgbClr val="202124"/>
                 </a:solidFill>
-                <a:latin typeface="Segoe UI" panose="020B0502040204020203"/>
-                <a:ea typeface="Segoe UI" panose="020B0502040204020203"/>
-                <a:cs typeface="Segoe UI" panose="020B0502040204020203"/>
+                <a:latin typeface="Segoe UI"/>
+                <a:ea typeface="Segoe UI"/>
+                <a:cs typeface="Segoe UI"/>
               </a:rPr>
               <a:t>Лестница живого мира</a:t>
             </a:r>
@@ -1922,9 +1797,9 @@
                 <a:solidFill>
                   <a:srgbClr val="5F6368"/>
                 </a:solidFill>
-                <a:latin typeface="Segoe UI" panose="020B0502040204020203"/>
-                <a:ea typeface="Segoe UI" panose="020B0502040204020203"/>
-                <a:cs typeface="Segoe UI" panose="020B0502040204020203"/>
+                <a:latin typeface="Segoe UI"/>
+                <a:ea typeface="Segoe UI"/>
+                <a:cs typeface="Segoe UI"/>
               </a:rPr>
               <a:t>Живой мир Линней расположил по группам одна внутри другой — как матрёшки.</a:t>
             </a:r>
@@ -2022,9 +1897,9 @@
                 <a:solidFill>
                   <a:srgbClr val="FFFFFF"/>
                 </a:solidFill>
-                <a:latin typeface="Segoe UI" panose="020B0502040204020203"/>
-                <a:ea typeface="Segoe UI" panose="020B0502040204020203"/>
-                <a:cs typeface="Segoe UI" panose="020B0502040204020203"/>
+                <a:latin typeface="Segoe UI"/>
+                <a:ea typeface="Segoe UI"/>
+                <a:cs typeface="Segoe UI"/>
               </a:rPr>
               <a:t>класс</a:t>
             </a:r>
@@ -2071,9 +1946,9 @@
                 <a:solidFill>
                   <a:srgbClr val="202124"/>
                 </a:solidFill>
-                <a:latin typeface="Segoe UI" panose="020B0502040204020203"/>
-                <a:ea typeface="Segoe UI" panose="020B0502040204020203"/>
-                <a:cs typeface="Segoe UI" panose="020B0502040204020203"/>
+                <a:latin typeface="Segoe UI"/>
+                <a:ea typeface="Segoe UI"/>
+                <a:cs typeface="Segoe UI"/>
               </a:rPr>
               <a:t>самая большая группа похожих существ</a:t>
             </a:r>
@@ -2171,9 +2046,9 @@
                 <a:solidFill>
                   <a:srgbClr val="FFFFFF"/>
                 </a:solidFill>
-                <a:latin typeface="Segoe UI" panose="020B0502040204020203"/>
-                <a:ea typeface="Segoe UI" panose="020B0502040204020203"/>
-                <a:cs typeface="Segoe UI" panose="020B0502040204020203"/>
+                <a:latin typeface="Segoe UI"/>
+                <a:ea typeface="Segoe UI"/>
+                <a:cs typeface="Segoe UI"/>
               </a:rPr>
               <a:t>отряд / порядок</a:t>
             </a:r>
@@ -2220,9 +2095,9 @@
                 <a:solidFill>
                   <a:srgbClr val="202124"/>
                 </a:solidFill>
-                <a:latin typeface="Segoe UI" panose="020B0502040204020203"/>
-                <a:ea typeface="Segoe UI" panose="020B0502040204020203"/>
-                <a:cs typeface="Segoe UI" panose="020B0502040204020203"/>
+                <a:latin typeface="Segoe UI"/>
+                <a:ea typeface="Segoe UI"/>
+                <a:cs typeface="Segoe UI"/>
               </a:rPr>
               <a:t>поменьше, внутри класса</a:t>
             </a:r>
@@ -2320,9 +2195,9 @@
                 <a:solidFill>
                   <a:srgbClr val="202124"/>
                 </a:solidFill>
-                <a:latin typeface="Segoe UI" panose="020B0502040204020203"/>
-                <a:ea typeface="Segoe UI" panose="020B0502040204020203"/>
-                <a:cs typeface="Segoe UI" panose="020B0502040204020203"/>
+                <a:latin typeface="Segoe UI"/>
+                <a:ea typeface="Segoe UI"/>
+                <a:cs typeface="Segoe UI"/>
               </a:rPr>
               <a:t>род</a:t>
             </a:r>
@@ -2369,9 +2244,9 @@
                 <a:solidFill>
                   <a:srgbClr val="202124"/>
                 </a:solidFill>
-                <a:latin typeface="Segoe UI" panose="020B0502040204020203"/>
-                <a:ea typeface="Segoe UI" panose="020B0502040204020203"/>
-                <a:cs typeface="Segoe UI" panose="020B0502040204020203"/>
+                <a:latin typeface="Segoe UI"/>
+                <a:ea typeface="Segoe UI"/>
+                <a:cs typeface="Segoe UI"/>
               </a:rPr>
               <a:t>очень похожие друг на друга</a:t>
             </a:r>
@@ -2469,9 +2344,9 @@
                 <a:solidFill>
                   <a:srgbClr val="FFFFFF"/>
                 </a:solidFill>
-                <a:latin typeface="Segoe UI" panose="020B0502040204020203"/>
-                <a:ea typeface="Segoe UI" panose="020B0502040204020203"/>
-                <a:cs typeface="Segoe UI" panose="020B0502040204020203"/>
+                <a:latin typeface="Segoe UI"/>
+                <a:ea typeface="Segoe UI"/>
+                <a:cs typeface="Segoe UI"/>
               </a:rPr>
               <a:t>вид</a:t>
             </a:r>
@@ -2518,9 +2393,9 @@
                 <a:solidFill>
                   <a:srgbClr val="202124"/>
                 </a:solidFill>
-                <a:latin typeface="Segoe UI" panose="020B0502040204020203"/>
-                <a:ea typeface="Segoe UI" panose="020B0502040204020203"/>
-                <a:cs typeface="Segoe UI" panose="020B0502040204020203"/>
+                <a:latin typeface="Segoe UI"/>
+                <a:ea typeface="Segoe UI"/>
+                <a:cs typeface="Segoe UI"/>
               </a:rPr>
               <a:t>самая маленькая группа — одно существо</a:t>
             </a:r>
@@ -2624,9 +2499,9 @@
                 <a:solidFill>
                   <a:srgbClr val="202124"/>
                 </a:solidFill>
-                <a:latin typeface="Segoe UI" panose="020B0502040204020203"/>
-                <a:ea typeface="Segoe UI" panose="020B0502040204020203"/>
-                <a:cs typeface="Segoe UI" panose="020B0502040204020203"/>
+                <a:latin typeface="Segoe UI"/>
+                <a:ea typeface="Segoe UI"/>
+                <a:cs typeface="Segoe UI"/>
               </a:rPr>
               <a:t>интересные факты</a:t>
             </a:r>
@@ -2673,9 +2548,9 @@
                 <a:solidFill>
                   <a:srgbClr val="202124"/>
                 </a:solidFill>
-                <a:latin typeface="Segoe UI" panose="020B0502040204020203"/>
-                <a:ea typeface="Segoe UI" panose="020B0502040204020203"/>
-                <a:cs typeface="Segoe UI" panose="020B0502040204020203"/>
+                <a:latin typeface="Segoe UI"/>
+                <a:ea typeface="Segoe UI"/>
+                <a:cs typeface="Segoe UI"/>
               </a:rPr>
               <a:t>Знаешь ли ты?</a:t>
             </a:r>
@@ -2773,9 +2648,9 @@
                 <a:solidFill>
                   <a:srgbClr val="202124"/>
                 </a:solidFill>
-                <a:latin typeface="Segoe UI" panose="020B0502040204020203"/>
-                <a:ea typeface="Segoe UI" panose="020B0502040204020203"/>
-                <a:cs typeface="Segoe UI" panose="020B0502040204020203"/>
+                <a:latin typeface="Segoe UI"/>
+                <a:ea typeface="Segoe UI"/>
+                <a:cs typeface="Segoe UI"/>
               </a:rPr>
               <a:t>Линней назвал человека Homo sapiens — «человек разумный».</a:t>
             </a:r>
@@ -2873,9 +2748,9 @@
                 <a:solidFill>
                   <a:srgbClr val="202124"/>
                 </a:solidFill>
-                <a:latin typeface="Segoe UI" panose="020B0502040204020203"/>
-                <a:ea typeface="Segoe UI" panose="020B0502040204020203"/>
-                <a:cs typeface="Segoe UI" panose="020B0502040204020203"/>
+                <a:latin typeface="Segoe UI"/>
+                <a:ea typeface="Segoe UI"/>
+                <a:cs typeface="Segoe UI"/>
               </a:rPr>
               <a:t>Книга «Система природы» (1735) описывает весь живой мир.</a:t>
             </a:r>
@@ -2973,9 +2848,9 @@
                 <a:solidFill>
                   <a:srgbClr val="202124"/>
                 </a:solidFill>
-                <a:latin typeface="Segoe UI" panose="020B0502040204020203"/>
-                <a:ea typeface="Segoe UI" panose="020B0502040204020203"/>
-                <a:cs typeface="Segoe UI" panose="020B0502040204020203"/>
+                <a:latin typeface="Segoe UI"/>
+                <a:ea typeface="Segoe UI"/>
+                <a:cs typeface="Segoe UI"/>
               </a:rPr>
               <a:t>«Виды растений» (1753) — описания всех известных растений.</a:t>
             </a:r>
@@ -3073,9 +2948,9 @@
                 <a:solidFill>
                   <a:srgbClr val="202124"/>
                 </a:solidFill>
-                <a:latin typeface="Segoe UI" panose="020B0502040204020203"/>
-                <a:ea typeface="Segoe UI" panose="020B0502040204020203"/>
-                <a:cs typeface="Segoe UI" panose="020B0502040204020203"/>
+                <a:latin typeface="Segoe UI"/>
+                <a:ea typeface="Segoe UI"/>
+                <a:cs typeface="Segoe UI"/>
               </a:rPr>
               <a:t>Символы ♂ и ♀ для мужского и женского придумал именно он.</a:t>
             </a:r>
@@ -3124,7 +2999,7 @@
         </p:nvSpPr>
         <p:spPr>
           <a:xfrm>
-            <a:off x="762000" y="1153220"/>
+            <a:off x="762000" y="946845"/>
             <a:ext cx="448965" cy="254000"/>
           </a:xfrm>
           <a:prstGeom prst="roundRect">
@@ -3148,7 +3023,7 @@
         </p:nvSpPr>
         <p:spPr>
           <a:xfrm>
-            <a:off x="876300" y="1191320"/>
+            <a:off x="876300" y="984945"/>
             <a:ext cx="220365" cy="152400"/>
           </a:xfrm>
           <a:prstGeom prst="rect">
@@ -3179,9 +3054,9 @@
                 <a:solidFill>
                   <a:srgbClr val="FFFFFF"/>
                 </a:solidFill>
-                <a:latin typeface="Segoe UI" panose="020B0502040204020203"/>
-                <a:ea typeface="Segoe UI" panose="020B0502040204020203"/>
-                <a:cs typeface="Segoe UI" panose="020B0502040204020203"/>
+                <a:latin typeface="Segoe UI"/>
+                <a:ea typeface="Segoe UI"/>
+                <a:cs typeface="Segoe UI"/>
               </a:rPr>
               <a:t>итог</a:t>
             </a:r>
@@ -3197,7 +3072,7 @@
         </p:nvSpPr>
         <p:spPr>
           <a:xfrm>
-            <a:off x="4404717" y="1646039"/>
+            <a:off x="4404717" y="1439664"/>
             <a:ext cx="3382466" cy="1173361"/>
           </a:xfrm>
           <a:prstGeom prst="rect">
@@ -3228,9 +3103,9 @@
                 <a:solidFill>
                   <a:srgbClr val="202124"/>
                 </a:solidFill>
-                <a:latin typeface="Segoe UI" panose="020B0502040204020203"/>
-                <a:ea typeface="Segoe UI" panose="020B0502040204020203"/>
-                <a:cs typeface="Segoe UI" panose="020B0502040204020203"/>
+                <a:latin typeface="Segoe UI"/>
+                <a:ea typeface="Segoe UI"/>
+                <a:cs typeface="Segoe UI"/>
               </a:rPr>
               <a:t>Спасибо</a:t>
             </a:r>
@@ -3242,9 +3117,9 @@
                 <a:solidFill>
                   <a:srgbClr val="202124"/>
                 </a:solidFill>
-                <a:latin typeface="Segoe UI" panose="020B0502040204020203"/>
-                <a:ea typeface="Segoe UI" panose="020B0502040204020203"/>
-                <a:cs typeface="Segoe UI" panose="020B0502040204020203"/>
+                <a:latin typeface="Segoe UI"/>
+                <a:ea typeface="Segoe UI"/>
+                <a:cs typeface="Segoe UI"/>
               </a:rPr>
               <a:t>за внимание!</a:t>
             </a:r>
@@ -3260,7 +3135,7 @@
         </p:nvSpPr>
         <p:spPr>
           <a:xfrm>
-            <a:off x="3533279" y="2891730"/>
+            <a:off x="3533279" y="2685355"/>
             <a:ext cx="5125442" cy="266700"/>
           </a:xfrm>
           <a:prstGeom prst="rect">
@@ -3291,9 +3166,9 @@
                 <a:solidFill>
                   <a:srgbClr val="5F6368"/>
                 </a:solidFill>
-                <a:latin typeface="Segoe UI" panose="020B0502040204020203"/>
-                <a:ea typeface="Segoe UI" panose="020B0502040204020203"/>
-                <a:cs typeface="Segoe UI" panose="020B0502040204020203"/>
+                <a:latin typeface="Segoe UI"/>
+                <a:ea typeface="Segoe UI"/>
+                <a:cs typeface="Segoe UI"/>
               </a:rPr>
               <a:t>Систему Линнея используют учёные всего мира и по сей день.</a:t>
             </a:r>
@@ -3303,13 +3178,62 @@
       </p:sp>
       <p:sp>
         <p:nvSpPr>
-          <p:cNvPr id="6" name="Rounded Rectangle"/>
-          <p:cNvSpPr/>
-          <p:nvPr/>
-        </p:nvSpPr>
-        <p:spPr>
-          <a:xfrm>
-            <a:off x="5146675" y="3345755"/>
+          <p:cNvPr id="6" name="Text: Выполнила: Самушенко Вероника, ученица 5"/>
+          <p:cNvSpPr txBox="1"/>
+          <p:nvPr/>
+        </p:nvSpPr>
+        <p:spPr>
+          <a:xfrm>
+            <a:off x="4091682" y="3123505"/>
+            <a:ext cx="4008537" cy="247650"/>
+          </a:xfrm>
+          <a:prstGeom prst="rect">
+            <a:avLst/>
+          </a:prstGeom>
+          <a:noFill/>
+        </p:spPr>
+        <p:txBody>
+          <a:bodyPr wrap="none" lIns="0" tIns="0" rIns="0" bIns="0" rtlCol="0" anchor="t">
+            <a:noAutofit/>
+          </a:bodyPr>
+          <a:lstStyle/>
+          <a:p>
+            <a:pPr algn="ctr">
+              <a:lnSpc>
+                <a:spcPts val="1950"/>
+              </a:lnSpc>
+              <a:spcBef>
+                <a:spcPts val="0"/>
+              </a:spcBef>
+              <a:spcAft>
+                <a:spcPts val="0"/>
+              </a:spcAft>
+              <a:buNone/>
+            </a:pPr>
+            <a:r>
+              <a:rPr lang="en-US" sz="1300" spc="-4" dirty="0">
+                <a:solidFill>
+                  <a:srgbClr val="202124"/>
+                </a:solidFill>
+                <a:latin typeface="Segoe UI"/>
+                <a:ea typeface="Segoe UI"/>
+                <a:cs typeface="Segoe UI"/>
+              </a:rPr>
+              <a:t>Выполнила: Самушенко Вероника, ученица 5г класса</a:t>
+            </a:r>
+            <a:endParaRPr lang="en-US" sz="1300" dirty="0"/>
+          </a:p>
+        </p:txBody>
+      </p:sp>
+      <p:sp>
+        <p:nvSpPr>
+          <p:cNvPr id="7" name="Rounded Rectangle"/>
+          <p:cNvSpPr/>
+          <p:nvPr/>
+        </p:nvSpPr>
+        <p:spPr>
+          <a:xfrm>
+            <a:off x="5146675" y="3552130"/>
             <a:ext cx="1898650" cy="2355850"/>
           </a:xfrm>
           <a:prstGeom prst="roundRect">
@@ -3328,22 +3252,22 @@
       </p:sp>
       <p:pic>
         <p:nvPicPr>
-          <p:cNvPr id="7" name="Image: Портрет Линнея"/>
+          <p:cNvPr id="8" name="Image: Портрет Линнея"/>
           <p:cNvPicPr>
             <a:picLocks noChangeAspect="1"/>
           </p:cNvPicPr>
           <p:nvPr/>
         </p:nvPicPr>
         <p:blipFill>
-          <a:blip r:embed="rId1"/>
-          <a:srcRect t="949" b="949"/>
+          <a:blip r:embed="rId2"/>
+          <a:srcRect l="0" t="949" r="0" b="949"/>
           <a:stretch>
             <a:fillRect/>
           </a:stretch>
         </p:blipFill>
         <p:spPr>
           <a:xfrm>
-            <a:off x="5149850" y="3348930"/>
+            <a:off x="5149850" y="3555305"/>
             <a:ext cx="1892300" cy="2349500"/>
           </a:xfrm>
           <a:prstGeom prst="rect">
@@ -3547,10 +3471,5 @@
       </a:bgFillStyleLst>
     </a:fmtScheme>
   </a:themeElements>
-  <a:extLst>
-    <a:ext uri="{05A4C25C-085E-4340-85A3-A5531E510DB2}">
-      <thm15:themeFamily xmlns:thm15="http://schemas.microsoft.com/office/thememl/2012/main" name="Office Theme" id="{62F939B6-93AF-4DB8-9C6B-D6C7DFDC589F}" vid="{4A3C46E8-61CC-4603-A589-7422A47A8E4A}"/>
-    </a:ext>
-  </a:extLst>
 </a:theme>
 </file>
</xml_diff>